<commit_message>
TP vs FP 자료 추가
</commit_message>
<xml_diff>
--- a/docs/260724_Results_of_Residual_Algorithm.pptx
+++ b/docs/260724_Results_of_Residual_Algorithm.pptx
@@ -10280,112 +10280,83 @@
             <p:ph idx="1"/>
           </p:nvPr>
         </p:nvSpPr>
-        <p:spPr/>
+        <p:spPr>
+          <a:xfrm>
+            <a:off x="508000" y="897468"/>
+            <a:ext cx="11038774" cy="5063066"/>
+          </a:xfrm>
+        </p:spPr>
         <p:txBody>
-          <a:bodyPr/>
+          <a:bodyPr>
+            <a:normAutofit/>
+          </a:bodyPr>
           <a:lstStyle/>
           <a:p>
             <a:r>
-              <a:rPr lang="en-US" altLang="ko-KR" dirty="0">
+              <a:rPr lang="en-US" altLang="ko-KR" sz="1800" dirty="0">
                 <a:latin typeface="KoPub돋움체 Bold" panose="00000800000000000000" pitchFamily="2" charset="-127"/>
                 <a:ea typeface="KoPub돋움체 Bold" panose="00000800000000000000" pitchFamily="2" charset="-127"/>
               </a:rPr>
-              <a:t>Stage 1 </a:t>
-            </a:r>
-            <a:r>
-              <a:rPr lang="ko-KR" altLang="en-US" dirty="0">
-                <a:latin typeface="KoPub돋움체 Bold" panose="00000800000000000000" pitchFamily="2" charset="-127"/>
-                <a:ea typeface="KoPub돋움체 Bold" panose="00000800000000000000" pitchFamily="2" charset="-127"/>
-              </a:rPr>
-              <a:t>오류 패턴 분석 </a:t>
-            </a:r>
-            <a:r>
-              <a:rPr lang="en-US" altLang="ko-KR" dirty="0">
-                <a:latin typeface="KoPub돋움체 Bold" panose="00000800000000000000" pitchFamily="2" charset="-127"/>
-                <a:ea typeface="KoPub돋움체 Bold" panose="00000800000000000000" pitchFamily="2" charset="-127"/>
-              </a:rPr>
-              <a:t>(Error Feature Analysis)</a:t>
+              <a:t>Stage 1 screen-positive(TP/FP) 오류 패턴 분석 (Error Feature Analysis)</a:t>
             </a:r>
           </a:p>
           <a:p>
             <a:pPr lvl="1"/>
             <a:r>
-              <a:rPr lang="ko-KR" altLang="en-US" dirty="0"/>
-              <a:t>결론</a:t>
-            </a:r>
-            <a:r>
-              <a:rPr lang="en-US" altLang="ko-KR" dirty="0"/>
-              <a:t>: </a:t>
-            </a:r>
-            <a:r>
-              <a:rPr lang="ko-KR" altLang="en-US" dirty="0"/>
-              <a:t>키</a:t>
-            </a:r>
-            <a:r>
-              <a:rPr lang="en-US" altLang="ko-KR" dirty="0"/>
-              <a:t>/</a:t>
-            </a:r>
-            <a:r>
-              <a:rPr lang="ko-KR" altLang="en-US" dirty="0"/>
-              <a:t>몸무게 같은 </a:t>
-            </a:r>
-            <a:r>
-              <a:rPr lang="en-US" altLang="ko-KR" dirty="0"/>
-              <a:t>clinic </a:t>
-            </a:r>
-            <a:r>
-              <a:rPr lang="ko-KR" altLang="en-US" dirty="0"/>
-              <a:t>변수만으로는 체지방과 </a:t>
-            </a:r>
-            <a:r>
-              <a:rPr lang="ko-KR" altLang="en-US" dirty="0" err="1"/>
-              <a:t>근육량을</a:t>
-            </a:r>
-            <a:r>
-              <a:rPr lang="ko-KR" altLang="en-US" dirty="0"/>
-              <a:t> 구분할 수 없다</a:t>
-            </a:r>
-            <a:endParaRPr lang="en-US" altLang="ko-KR" dirty="0"/>
-          </a:p>
-          <a:p>
-            <a:pPr lvl="1"/>
-            <a:r>
-              <a:rPr lang="ko-KR" altLang="en-US" dirty="0"/>
-              <a:t>→ 실제 </a:t>
-            </a:r>
-            <a:r>
-              <a:rPr lang="ko-KR" altLang="en-US" dirty="0" err="1"/>
-              <a:t>근육량을</a:t>
-            </a:r>
-            <a:r>
-              <a:rPr lang="ko-KR" altLang="en-US" dirty="0"/>
-              <a:t> 보는 영상</a:t>
-            </a:r>
-            <a:r>
-              <a:rPr lang="en-US" altLang="ko-KR" dirty="0"/>
-              <a:t>(CT) </a:t>
-            </a:r>
-            <a:r>
-              <a:rPr lang="ko-KR" altLang="en-US" dirty="0"/>
-              <a:t>기반 </a:t>
-            </a:r>
-            <a:r>
-              <a:rPr lang="en-US" altLang="ko-KR" dirty="0"/>
-              <a:t>Stage 2</a:t>
-            </a:r>
-            <a:r>
-              <a:rPr lang="ko-KR" altLang="en-US" dirty="0"/>
-              <a:t>가 필요한 이유</a:t>
+              <a:rPr lang="ko-KR" altLang="en-US" sz="1600" dirty="0"/>
+              <a:t>결론: TP-FP 간 bmi/height/weight도 유의하게 다르지만(p&lt;0.03), 그 차이만으로는 screen의 오탐(FP)을 걸러내지 못한다</a:t>
+            </a:r>
+            <a:endParaRPr lang="en-US" altLang="ko-KR" sz="1600" dirty="0"/>
+          </a:p>
+          <a:p>
+            <a:pPr marL="457200" lvl="1" indent="0">
+              <a:buNone/>
+            </a:pPr>
+            <a:r>
+              <a:rPr lang="ko-KR" altLang="en-US" sz="1600" dirty="0"/>
+              <a:t>→ CT(AEC-128) 기반 정보가 필요한 이유 (AEC는 모든 CT 촬영 시 스캐너가 자동 기록하는 데이터 </a:t>
+            </a:r>
+            <a:r>
+              <a:rPr lang="en-US" altLang="ko-KR" sz="1600" dirty="0"/>
+              <a:t>-</a:t>
+            </a:r>
+            <a:r>
+              <a:rPr lang="ko-KR" altLang="en-US" sz="1600" dirty="0"/>
+              <a:t> 세그멘테이션 없이 추가 비용 없이 얻을 수 있는 신호)</a:t>
             </a:r>
           </a:p>
         </p:txBody>
       </p:sp>
+      <p:pic>
+        <p:nvPicPr>
+          <p:cNvPr id="6" name="Picture 5" descr="tp_vs_fp_scatter.png"/>
+          <p:cNvPicPr>
+            <a:picLocks noChangeAspect="1"/>
+          </p:cNvPicPr>
+          <p:nvPr/>
+        </p:nvPicPr>
+        <p:blipFill>
+          <a:blip r:embed="rId3"/>
+          <a:stretch>
+            <a:fillRect/>
+          </a:stretch>
+        </p:blipFill>
+        <p:spPr>
+          <a:xfrm>
+            <a:off x="7085319" y="3206338"/>
+            <a:ext cx="4598681" cy="3103418"/>
+          </a:xfrm>
+          <a:prstGeom prst="rect">
+            <a:avLst/>
+          </a:prstGeom>
+        </p:spPr>
+      </p:pic>
       <p:graphicFrame>
         <p:nvGraphicFramePr>
-          <p:cNvPr id="5" name="Table 4">
+          <p:cNvPr id="4" name="표 3">
             <a:extLst>
               <a:ext uri="{FF2B5EF4-FFF2-40B4-BE49-F238E27FC236}">
-                <a16:creationId xmlns:a16="http://schemas.microsoft.com/office/drawing/2014/main" id="{AD8EFA6F-1755-6A57-6F33-7094CD62C7F0}"/>
+                <a16:creationId xmlns:a16="http://schemas.microsoft.com/office/drawing/2014/main" id="{6783CF32-47FA-C908-47D8-C963EB5ADDC6}"/>
               </a:ext>
             </a:extLst>
           </p:cNvPr>
@@ -10395,14 +10366,14 @@
           <p:nvPr>
             <p:extLst>
               <p:ext uri="{D42A27DB-BD31-4B8C-83A1-F6EECF244321}">
-                <p14:modId xmlns:p14="http://schemas.microsoft.com/office/powerpoint/2010/main" val="671317018"/>
+                <p14:modId xmlns:p14="http://schemas.microsoft.com/office/powerpoint/2010/main" val="2666102397"/>
               </p:ext>
             </p:extLst>
           </p:nvPr>
         </p:nvGraphicFramePr>
         <p:xfrm>
-          <a:off x="731520" y="2831911"/>
-          <a:ext cx="10698480" cy="1569368"/>
+          <a:off x="567374" y="3206338"/>
+          <a:ext cx="6090720" cy="1483360"/>
         </p:xfrm>
         <a:graphic>
           <a:graphicData uri="http://schemas.openxmlformats.org/drawingml/2006/table">
@@ -10411,50 +10382,50 @@
                 <a:tableStyleId>{9D7B26C5-4107-4FEC-AEDC-1716B250A1EF}</a:tableStyleId>
               </a:tblPr>
               <a:tblGrid>
-                <a:gridCol w="1783080">
+                <a:gridCol w="1015120">
                   <a:extLst>
                     <a:ext uri="{9D8B030D-6E8A-4147-A177-3AD203B41FA5}">
-                      <a16:colId xmlns:a16="http://schemas.microsoft.com/office/drawing/2014/main" val="20000"/>
+                      <a16:colId xmlns:a16="http://schemas.microsoft.com/office/drawing/2014/main" val="2297975198"/>
                     </a:ext>
                   </a:extLst>
                 </a:gridCol>
-                <a:gridCol w="1783080">
+                <a:gridCol w="1015120">
                   <a:extLst>
                     <a:ext uri="{9D8B030D-6E8A-4147-A177-3AD203B41FA5}">
-                      <a16:colId xmlns:a16="http://schemas.microsoft.com/office/drawing/2014/main" val="20001"/>
+                      <a16:colId xmlns:a16="http://schemas.microsoft.com/office/drawing/2014/main" val="1011738737"/>
                     </a:ext>
                   </a:extLst>
                 </a:gridCol>
-                <a:gridCol w="1783080">
+                <a:gridCol w="1015120">
                   <a:extLst>
                     <a:ext uri="{9D8B030D-6E8A-4147-A177-3AD203B41FA5}">
-                      <a16:colId xmlns:a16="http://schemas.microsoft.com/office/drawing/2014/main" val="20002"/>
+                      <a16:colId xmlns:a16="http://schemas.microsoft.com/office/drawing/2014/main" val="291453867"/>
                     </a:ext>
                   </a:extLst>
                 </a:gridCol>
-                <a:gridCol w="1783080">
+                <a:gridCol w="1015120">
                   <a:extLst>
                     <a:ext uri="{9D8B030D-6E8A-4147-A177-3AD203B41FA5}">
-                      <a16:colId xmlns:a16="http://schemas.microsoft.com/office/drawing/2014/main" val="20003"/>
+                      <a16:colId xmlns:a16="http://schemas.microsoft.com/office/drawing/2014/main" val="1154735498"/>
                     </a:ext>
                   </a:extLst>
                 </a:gridCol>
-                <a:gridCol w="1783080">
+                <a:gridCol w="1015120">
                   <a:extLst>
                     <a:ext uri="{9D8B030D-6E8A-4147-A177-3AD203B41FA5}">
-                      <a16:colId xmlns:a16="http://schemas.microsoft.com/office/drawing/2014/main" val="20004"/>
+                      <a16:colId xmlns:a16="http://schemas.microsoft.com/office/drawing/2014/main" val="4279169750"/>
                     </a:ext>
                   </a:extLst>
                 </a:gridCol>
-                <a:gridCol w="1783080">
+                <a:gridCol w="1015120">
                   <a:extLst>
                     <a:ext uri="{9D8B030D-6E8A-4147-A177-3AD203B41FA5}">
-                      <a16:colId xmlns:a16="http://schemas.microsoft.com/office/drawing/2014/main" val="20005"/>
+                      <a16:colId xmlns:a16="http://schemas.microsoft.com/office/drawing/2014/main" val="1848357860"/>
                     </a:ext>
                   </a:extLst>
                 </a:gridCol>
               </a:tblGrid>
-              <a:tr h="392342">
+              <a:tr h="370840">
                 <a:tc>
                   <a:txBody>
                     <a:bodyPr/>
@@ -10477,8 +10448,8 @@
                     <a:p>
                       <a:pPr algn="ctr"/>
                       <a:r>
-                        <a:rPr sz="1300" b="1"/>
-                        <a:t>Group A (mean)</a:t>
+                        <a:rPr sz="1300"/>
+                        <a:t>TP (mean)</a:t>
                       </a:r>
                     </a:p>
                   </a:txBody>
@@ -10491,8 +10462,8 @@
                     <a:p>
                       <a:pPr algn="ctr"/>
                       <a:r>
-                        <a:rPr sz="1300" b="1"/>
-                        <a:t>Group B (mean)</a:t>
+                        <a:rPr sz="1300"/>
+                        <a:t>FP (mean)</a:t>
                       </a:r>
                     </a:p>
                   </a:txBody>
@@ -10542,11 +10513,11 @@
                 </a:tc>
                 <a:extLst>
                   <a:ext uri="{0D108BD9-81ED-4DB2-BD59-A6C34878D82A}">
-                    <a16:rowId xmlns:a16="http://schemas.microsoft.com/office/drawing/2014/main" val="10000"/>
+                    <a16:rowId xmlns:a16="http://schemas.microsoft.com/office/drawing/2014/main" val="1129282602"/>
                   </a:ext>
                 </a:extLst>
               </a:tr>
-              <a:tr h="392342">
+              <a:tr h="370840">
                 <a:tc>
                   <a:txBody>
                     <a:bodyPr/>
@@ -10554,8 +10525,8 @@
                     <a:p>
                       <a:pPr algn="ctr"/>
                       <a:r>
-                        <a:rPr sz="1300"/>
-                        <a:t>BMI: TP vs FN</a:t>
+                        <a:rPr sz="1300" dirty="0"/>
+                        <a:t>BMI</a:t>
                       </a:r>
                     </a:p>
                   </a:txBody>
@@ -10568,7 +10539,7 @@
                     <a:p>
                       <a:pPr algn="ctr"/>
                       <a:r>
-                        <a:rPr sz="1300"/>
+                        <a:rPr sz="1300" dirty="0"/>
                         <a:t>20.62 (TP)</a:t>
                       </a:r>
                     </a:p>
@@ -10582,98 +10553,7 @@
                     <a:p>
                       <a:pPr algn="ctr"/>
                       <a:r>
-                        <a:rPr sz="1300"/>
-                        <a:t>24.72 (FN)</a:t>
-                      </a:r>
-                    </a:p>
-                  </a:txBody>
-                  <a:tcPr anchor="ctr"/>
-                </a:tc>
-                <a:tc>
-                  <a:txBody>
-                    <a:bodyPr/>
-                    <a:lstStyle/>
-                    <a:p>
-                      <a:pPr algn="ctr"/>
-                      <a:r>
-                        <a:rPr sz="1300"/>
-                        <a:t>-4.10</a:t>
-                      </a:r>
-                    </a:p>
-                  </a:txBody>
-                  <a:tcPr anchor="ctr"/>
-                </a:tc>
-                <a:tc>
-                  <a:txBody>
-                    <a:bodyPr/>
-                    <a:lstStyle/>
-                    <a:p>
-                      <a:pPr algn="ctr"/>
-                      <a:r>
-                        <a:rPr sz="1300"/>
-                        <a:t>-4.50</a:t>
-                      </a:r>
-                    </a:p>
-                  </a:txBody>
-                  <a:tcPr anchor="ctr"/>
-                </a:tc>
-                <a:tc>
-                  <a:txBody>
-                    <a:bodyPr/>
-                    <a:lstStyle/>
-                    <a:p>
-                      <a:pPr algn="ctr"/>
-                      <a:r>
-                        <a:rPr sz="1300"/>
-                        <a:t>0.0006</a:t>
-                      </a:r>
-                    </a:p>
-                  </a:txBody>
-                  <a:tcPr anchor="ctr"/>
-                </a:tc>
-                <a:extLst>
-                  <a:ext uri="{0D108BD9-81ED-4DB2-BD59-A6C34878D82A}">
-                    <a16:rowId xmlns:a16="http://schemas.microsoft.com/office/drawing/2014/main" val="10001"/>
-                  </a:ext>
-                </a:extLst>
-              </a:tr>
-              <a:tr h="392342">
-                <a:tc>
-                  <a:txBody>
-                    <a:bodyPr/>
-                    <a:lstStyle/>
-                    <a:p>
-                      <a:pPr algn="ctr"/>
-                      <a:r>
-                        <a:rPr sz="1300"/>
-                        <a:t>BMI: TN vs FP</a:t>
-                      </a:r>
-                    </a:p>
-                  </a:txBody>
-                  <a:tcPr anchor="ctr"/>
-                </a:tc>
-                <a:tc>
-                  <a:txBody>
-                    <a:bodyPr/>
-                    <a:lstStyle/>
-                    <a:p>
-                      <a:pPr algn="ctr"/>
-                      <a:r>
-                        <a:rPr sz="1300"/>
-                        <a:t>25.40 (TN)</a:t>
-                      </a:r>
-                    </a:p>
-                  </a:txBody>
-                  <a:tcPr anchor="ctr"/>
-                </a:tc>
-                <a:tc>
-                  <a:txBody>
-                    <a:bodyPr/>
-                    <a:lstStyle/>
-                    <a:p>
-                      <a:pPr algn="ctr"/>
-                      <a:r>
-                        <a:rPr sz="1300"/>
+                        <a:rPr sz="1300" dirty="0"/>
                         <a:t>21.95 (FP)</a:t>
                       </a:r>
                     </a:p>
@@ -10688,7 +10568,7 @@
                       <a:pPr algn="ctr"/>
                       <a:r>
                         <a:rPr sz="1300"/>
-                        <a:t>+3.45</a:t>
+                        <a:t>-1.33</a:t>
                       </a:r>
                     </a:p>
                   </a:txBody>
@@ -10702,7 +10582,7 @@
                       <a:pPr algn="ctr"/>
                       <a:r>
                         <a:rPr sz="1300"/>
-                        <a:t>22.09</a:t>
+                        <a:t>-4.80</a:t>
                       </a:r>
                     </a:p>
                   </a:txBody>
@@ -10715,7 +10595,7 @@
                     <a:p>
                       <a:pPr algn="ctr"/>
                       <a:r>
-                        <a:rPr sz="1300"/>
+                        <a:rPr sz="1300" dirty="0"/>
                         <a:t>&lt;0.001</a:t>
                       </a:r>
                     </a:p>
@@ -10724,11 +10604,11 @@
                 </a:tc>
                 <a:extLst>
                   <a:ext uri="{0D108BD9-81ED-4DB2-BD59-A6C34878D82A}">
-                    <a16:rowId xmlns:a16="http://schemas.microsoft.com/office/drawing/2014/main" val="10002"/>
+                    <a16:rowId xmlns:a16="http://schemas.microsoft.com/office/drawing/2014/main" val="3169079054"/>
                   </a:ext>
                 </a:extLst>
               </a:tr>
-              <a:tr h="392342">
+              <a:tr h="370840">
                 <a:tc>
                   <a:txBody>
                     <a:bodyPr/>
@@ -10737,7 +10617,7 @@
                       <a:pPr algn="ctr"/>
                       <a:r>
                         <a:rPr sz="1300" dirty="0"/>
-                        <a:t>Height: TN vs FP</a:t>
+                        <a:t>Height</a:t>
                       </a:r>
                     </a:p>
                   </a:txBody>
@@ -10750,8 +10630,8 @@
                     <a:p>
                       <a:pPr algn="ctr"/>
                       <a:r>
-                        <a:rPr sz="1300"/>
-                        <a:t>158.48 (TN)</a:t>
+                        <a:rPr sz="1300" dirty="0"/>
+                        <a:t>166.96 (TP)</a:t>
                       </a:r>
                     </a:p>
                   </a:txBody>
@@ -10778,8 +10658,22 @@
                     <a:p>
                       <a:pPr algn="ctr"/>
                       <a:r>
-                        <a:rPr sz="1300"/>
-                        <a:t>-6.74</a:t>
+                        <a:rPr sz="1300" dirty="0"/>
+                        <a:t>+1.73</a:t>
+                      </a:r>
+                    </a:p>
+                  </a:txBody>
+                  <a:tcPr anchor="ctr"/>
+                </a:tc>
+                <a:tc>
+                  <a:txBody>
+                    <a:bodyPr/>
+                    <a:lstStyle/>
+                    <a:p>
+                      <a:pPr algn="ctr"/>
+                      <a:r>
+                        <a:rPr sz="1300" dirty="0"/>
+                        <a:t>2.32</a:t>
                       </a:r>
                     </a:p>
                   </a:txBody>
@@ -10793,7 +10687,70 @@
                       <a:pPr algn="ctr"/>
                       <a:r>
                         <a:rPr sz="1300"/>
-                        <a:t>-14.12</a:t>
+                        <a:t>0.0213</a:t>
+                      </a:r>
+                    </a:p>
+                  </a:txBody>
+                  <a:tcPr anchor="ctr"/>
+                </a:tc>
+                <a:extLst>
+                  <a:ext uri="{0D108BD9-81ED-4DB2-BD59-A6C34878D82A}">
+                    <a16:rowId xmlns:a16="http://schemas.microsoft.com/office/drawing/2014/main" val="1446832005"/>
+                  </a:ext>
+                </a:extLst>
+              </a:tr>
+              <a:tr h="370840">
+                <a:tc>
+                  <a:txBody>
+                    <a:bodyPr/>
+                    <a:lstStyle/>
+                    <a:p>
+                      <a:pPr algn="ctr"/>
+                      <a:r>
+                        <a:rPr sz="1300" dirty="0"/>
+                        <a:t>Weight</a:t>
+                      </a:r>
+                    </a:p>
+                  </a:txBody>
+                  <a:tcPr anchor="ctr"/>
+                </a:tc>
+                <a:tc>
+                  <a:txBody>
+                    <a:bodyPr/>
+                    <a:lstStyle/>
+                    <a:p>
+                      <a:pPr algn="ctr"/>
+                      <a:r>
+                        <a:rPr sz="1300"/>
+                        <a:t>57.86 (TP)</a:t>
+                      </a:r>
+                    </a:p>
+                  </a:txBody>
+                  <a:tcPr anchor="ctr"/>
+                </a:tc>
+                <a:tc>
+                  <a:txBody>
+                    <a:bodyPr/>
+                    <a:lstStyle/>
+                    <a:p>
+                      <a:pPr algn="ctr"/>
+                      <a:r>
+                        <a:rPr sz="1300"/>
+                        <a:t>60.31 (FP)</a:t>
+                      </a:r>
+                    </a:p>
+                  </a:txBody>
+                  <a:tcPr anchor="ctr"/>
+                </a:tc>
+                <a:tc>
+                  <a:txBody>
+                    <a:bodyPr/>
+                    <a:lstStyle/>
+                    <a:p>
+                      <a:pPr algn="ctr"/>
+                      <a:r>
+                        <a:rPr sz="1300"/>
+                        <a:t>-2.45</a:t>
                       </a:r>
                     </a:p>
                   </a:txBody>
@@ -10807,7 +10764,21 @@
                       <a:pPr algn="ctr"/>
                       <a:r>
                         <a:rPr sz="1300" dirty="0"/>
-                        <a:t>&lt;0.001</a:t>
+                        <a:t>-2.23</a:t>
+                      </a:r>
+                    </a:p>
+                  </a:txBody>
+                  <a:tcPr anchor="ctr"/>
+                </a:tc>
+                <a:tc>
+                  <a:txBody>
+                    <a:bodyPr/>
+                    <a:lstStyle/>
+                    <a:p>
+                      <a:pPr algn="ctr"/>
+                      <a:r>
+                        <a:rPr sz="1300" dirty="0"/>
+                        <a:t>0.0272</a:t>
                       </a:r>
                     </a:p>
                   </a:txBody>
@@ -10815,7 +10786,7 @@
                 </a:tc>
                 <a:extLst>
                   <a:ext uri="{0D108BD9-81ED-4DB2-BD59-A6C34878D82A}">
-                    <a16:rowId xmlns:a16="http://schemas.microsoft.com/office/drawing/2014/main" val="10003"/>
+                    <a16:rowId xmlns:a16="http://schemas.microsoft.com/office/drawing/2014/main" val="91012224"/>
                   </a:ext>
                 </a:extLst>
               </a:tr>
@@ -10888,6 +10859,548 @@
           </a:p>
         </p:txBody>
       </p:sp>
+      <p:sp>
+        <p:nvSpPr>
+          <p:cNvPr id="3" name="내용 개체 틀 2">
+            <a:extLst>
+              <a:ext uri="{FF2B5EF4-FFF2-40B4-BE49-F238E27FC236}">
+                <a16:creationId xmlns:a16="http://schemas.microsoft.com/office/drawing/2014/main" id="{3A2DAB41-2035-BDBA-E4F8-3F894B486658}"/>
+              </a:ext>
+            </a:extLst>
+          </p:cNvPr>
+          <p:cNvSpPr>
+            <a:spLocks noGrp="1"/>
+          </p:cNvSpPr>
+          <p:nvPr>
+            <p:ph idx="1"/>
+          </p:nvPr>
+        </p:nvSpPr>
+        <p:spPr/>
+        <p:txBody>
+          <a:bodyPr>
+            <a:normAutofit/>
+          </a:bodyPr>
+          <a:lstStyle/>
+          <a:p>
+            <a:r>
+              <a:rPr sz="1800" dirty="0"/>
+              <a:t>Stage 2 </a:t>
+            </a:r>
+            <a:r>
+              <a:rPr sz="1800" dirty="0" err="1"/>
+              <a:t>대상군</a:t>
+            </a:r>
+            <a:r>
+              <a:rPr sz="1800" dirty="0"/>
+              <a:t>(TP/FP) AEC-128 </a:t>
+            </a:r>
+            <a:r>
+              <a:rPr sz="1800" dirty="0" err="1"/>
+              <a:t>곡선</a:t>
+            </a:r>
+            <a:r>
+              <a:rPr sz="1800" dirty="0"/>
+              <a:t> </a:t>
+            </a:r>
+            <a:r>
+              <a:rPr sz="1800" dirty="0" err="1"/>
+              <a:t>비교</a:t>
+            </a:r>
+            <a:endParaRPr sz="1800" dirty="0"/>
+          </a:p>
+          <a:p>
+            <a:pPr lvl="1"/>
+            <a:r>
+              <a:rPr sz="1600" dirty="0"/>
+              <a:t>TP vs FP </a:t>
+            </a:r>
+            <a:r>
+              <a:rPr sz="1600" dirty="0" err="1"/>
+              <a:t>환자군의</a:t>
+            </a:r>
+            <a:r>
+              <a:rPr sz="1600" dirty="0"/>
+              <a:t> patient-normalized AEC-128 </a:t>
+            </a:r>
+            <a:r>
+              <a:rPr sz="1600" dirty="0" err="1"/>
+              <a:t>곡선</a:t>
+            </a:r>
+            <a:r>
+              <a:rPr sz="1600" dirty="0"/>
+              <a:t> </a:t>
+            </a:r>
+            <a:r>
+              <a:rPr sz="1600" dirty="0" err="1"/>
+              <a:t>비교</a:t>
+            </a:r>
+            <a:r>
+              <a:rPr sz="1600" dirty="0"/>
+              <a:t> (</a:t>
+            </a:r>
+            <a:r>
+              <a:rPr sz="1600" dirty="0" err="1"/>
+              <a:t>잔차화</a:t>
+            </a:r>
+            <a:r>
+              <a:rPr sz="1600" dirty="0"/>
+              <a:t> 전, raw curve)</a:t>
+            </a:r>
+          </a:p>
+          <a:p>
+            <a:pPr marL="457200" lvl="1" indent="0">
+              <a:buNone/>
+            </a:pPr>
+            <a:r>
+              <a:rPr sz="1600" dirty="0"/>
+              <a:t>→ raw </a:t>
+            </a:r>
+            <a:r>
+              <a:rPr sz="1600" dirty="0" err="1"/>
+              <a:t>AEC만으로는</a:t>
+            </a:r>
+            <a:r>
+              <a:rPr sz="1600" dirty="0"/>
+              <a:t> </a:t>
+            </a:r>
+            <a:r>
+              <a:rPr sz="1600" dirty="0" err="1"/>
+              <a:t>코호트</a:t>
+            </a:r>
+            <a:r>
+              <a:rPr sz="1600" dirty="0"/>
+              <a:t> 간 </a:t>
+            </a:r>
+            <a:r>
+              <a:rPr sz="1600" dirty="0" err="1"/>
+              <a:t>일관된</a:t>
+            </a:r>
+            <a:r>
+              <a:rPr sz="1600" dirty="0"/>
+              <a:t> TP/FP </a:t>
+            </a:r>
+            <a:r>
+              <a:rPr sz="1600" dirty="0" err="1"/>
+              <a:t>신호</a:t>
+            </a:r>
+            <a:r>
+              <a:rPr sz="1600" dirty="0"/>
+              <a:t> </a:t>
+            </a:r>
+            <a:r>
+              <a:rPr sz="1600" dirty="0" err="1"/>
+              <a:t>없음</a:t>
+            </a:r>
+            <a:r>
+              <a:rPr sz="1600" dirty="0"/>
+              <a:t> — clinical </a:t>
+            </a:r>
+            <a:r>
+              <a:rPr sz="1600" dirty="0" err="1"/>
+              <a:t>변수</a:t>
+            </a:r>
+            <a:r>
+              <a:rPr sz="1600" dirty="0"/>
+              <a:t> confound </a:t>
+            </a:r>
+            <a:r>
+              <a:rPr sz="1600" dirty="0" err="1"/>
+              <a:t>가능성</a:t>
+            </a:r>
+            <a:r>
+              <a:rPr sz="1600" dirty="0"/>
+              <a:t>, residual </a:t>
+            </a:r>
+            <a:r>
+              <a:rPr sz="1600" dirty="0" err="1"/>
+              <a:t>접근</a:t>
+            </a:r>
+            <a:r>
+              <a:rPr sz="1600" dirty="0"/>
+              <a:t> </a:t>
+            </a:r>
+            <a:r>
+              <a:rPr sz="1600" dirty="0" err="1"/>
+              <a:t>필요성을</a:t>
+            </a:r>
+            <a:r>
+              <a:rPr sz="1600" dirty="0"/>
+              <a:t> </a:t>
+            </a:r>
+            <a:r>
+              <a:rPr sz="1600" dirty="0" err="1"/>
+              <a:t>뒷받침</a:t>
+            </a:r>
+            <a:endParaRPr sz="1600" dirty="0"/>
+          </a:p>
+        </p:txBody>
+      </p:sp>
+      <p:grpSp>
+        <p:nvGrpSpPr>
+          <p:cNvPr id="7" name="그룹 6">
+            <a:extLst>
+              <a:ext uri="{FF2B5EF4-FFF2-40B4-BE49-F238E27FC236}">
+                <a16:creationId xmlns:a16="http://schemas.microsoft.com/office/drawing/2014/main" id="{26C388CB-8A1B-1F40-7549-1CEDA1A4F6F8}"/>
+              </a:ext>
+            </a:extLst>
+          </p:cNvPr>
+          <p:cNvGrpSpPr/>
+          <p:nvPr/>
+        </p:nvGrpSpPr>
+        <p:grpSpPr>
+          <a:xfrm>
+            <a:off x="1809738" y="3633441"/>
+            <a:ext cx="8572523" cy="2654186"/>
+            <a:chOff x="-2177264" y="198565"/>
+            <a:chExt cx="11304347" cy="3500001"/>
+          </a:xfrm>
+        </p:grpSpPr>
+        <p:pic>
+          <p:nvPicPr>
+            <p:cNvPr id="4" name="Picture 3" descr="16_aec_curve_tp_vs_fp.png"/>
+            <p:cNvPicPr>
+              <a:picLocks noChangeAspect="1"/>
+            </p:cNvPicPr>
+            <p:nvPr/>
+          </p:nvPicPr>
+          <p:blipFill>
+            <a:blip r:embed="rId3"/>
+            <a:stretch>
+              <a:fillRect/>
+            </a:stretch>
+          </p:blipFill>
+          <p:spPr>
+            <a:xfrm>
+              <a:off x="-2177264" y="198566"/>
+              <a:ext cx="5124000" cy="3500000"/>
+            </a:xfrm>
+            <a:prstGeom prst="rect">
+              <a:avLst/>
+            </a:prstGeom>
+          </p:spPr>
+        </p:pic>
+        <p:pic>
+          <p:nvPicPr>
+            <p:cNvPr id="5" name="Picture 4" descr="16_aec_curve_tp_vs_fp.png"/>
+            <p:cNvPicPr>
+              <a:picLocks noChangeAspect="1"/>
+            </p:cNvPicPr>
+            <p:nvPr/>
+          </p:nvPicPr>
+          <p:blipFill>
+            <a:blip r:embed="rId4"/>
+            <a:stretch>
+              <a:fillRect/>
+            </a:stretch>
+          </p:blipFill>
+          <p:spPr>
+            <a:xfrm>
+              <a:off x="4003083" y="198565"/>
+              <a:ext cx="5124000" cy="3499999"/>
+            </a:xfrm>
+            <a:prstGeom prst="rect">
+              <a:avLst/>
+            </a:prstGeom>
+          </p:spPr>
+        </p:pic>
+      </p:grpSp>
+      <p:graphicFrame>
+        <p:nvGraphicFramePr>
+          <p:cNvPr id="6" name="Table 5"/>
+          <p:cNvGraphicFramePr>
+            <a:graphicFrameLocks noGrp="1"/>
+          </p:cNvGraphicFramePr>
+          <p:nvPr>
+            <p:extLst>
+              <p:ext uri="{D42A27DB-BD31-4B8C-83A1-F6EECF244321}">
+                <p14:modId xmlns:p14="http://schemas.microsoft.com/office/powerpoint/2010/main" val="2546154062"/>
+              </p:ext>
+            </p:extLst>
+          </p:nvPr>
+        </p:nvGraphicFramePr>
+        <p:xfrm>
+          <a:off x="2500162" y="2429001"/>
+          <a:ext cx="7191675" cy="1000000"/>
+        </p:xfrm>
+        <a:graphic>
+          <a:graphicData uri="http://schemas.openxmlformats.org/drawingml/2006/table">
+            <a:tbl>
+              <a:tblPr firstRow="1" bandRow="1">
+                <a:tableStyleId>{9D7B26C5-4107-4FEC-AEDC-1716B250A1EF}</a:tableStyleId>
+              </a:tblPr>
+              <a:tblGrid>
+                <a:gridCol w="1438335">
+                  <a:extLst>
+                    <a:ext uri="{9D8B030D-6E8A-4147-A177-3AD203B41FA5}">
+                      <a16:colId xmlns:a16="http://schemas.microsoft.com/office/drawing/2014/main" val="20000"/>
+                    </a:ext>
+                  </a:extLst>
+                </a:gridCol>
+                <a:gridCol w="1438335">
+                  <a:extLst>
+                    <a:ext uri="{9D8B030D-6E8A-4147-A177-3AD203B41FA5}">
+                      <a16:colId xmlns:a16="http://schemas.microsoft.com/office/drawing/2014/main" val="20001"/>
+                    </a:ext>
+                  </a:extLst>
+                </a:gridCol>
+                <a:gridCol w="1438335">
+                  <a:extLst>
+                    <a:ext uri="{9D8B030D-6E8A-4147-A177-3AD203B41FA5}">
+                      <a16:colId xmlns:a16="http://schemas.microsoft.com/office/drawing/2014/main" val="20002"/>
+                    </a:ext>
+                  </a:extLst>
+                </a:gridCol>
+                <a:gridCol w="1438335">
+                  <a:extLst>
+                    <a:ext uri="{9D8B030D-6E8A-4147-A177-3AD203B41FA5}">
+                      <a16:colId xmlns:a16="http://schemas.microsoft.com/office/drawing/2014/main" val="20003"/>
+                    </a:ext>
+                  </a:extLst>
+                </a:gridCol>
+                <a:gridCol w="1438335">
+                  <a:extLst>
+                    <a:ext uri="{9D8B030D-6E8A-4147-A177-3AD203B41FA5}">
+                      <a16:colId xmlns:a16="http://schemas.microsoft.com/office/drawing/2014/main" val="20004"/>
+                    </a:ext>
+                  </a:extLst>
+                </a:gridCol>
+              </a:tblGrid>
+              <a:tr h="333333">
+                <a:tc>
+                  <a:txBody>
+                    <a:bodyPr/>
+                    <a:lstStyle/>
+                    <a:p>
+                      <a:pPr algn="ctr"/>
+                      <a:r>
+                        <a:rPr sz="1200"/>
+                        <a:t>코호트</a:t>
+                      </a:r>
+                    </a:p>
+                  </a:txBody>
+                  <a:tcPr anchor="ctr"/>
+                </a:tc>
+                <a:tc>
+                  <a:txBody>
+                    <a:bodyPr/>
+                    <a:lstStyle/>
+                    <a:p>
+                      <a:pPr algn="ctr"/>
+                      <a:r>
+                        <a:rPr sz="1200"/>
+                        <a:t>curve RMSD</a:t>
+                      </a:r>
+                    </a:p>
+                  </a:txBody>
+                  <a:tcPr anchor="ctr"/>
+                </a:tc>
+                <a:tc>
+                  <a:txBody>
+                    <a:bodyPr/>
+                    <a:lstStyle/>
+                    <a:p>
+                      <a:pPr algn="ctr"/>
+                      <a:r>
+                        <a:rPr sz="1200"/>
+                        <a:t>perm p</a:t>
+                      </a:r>
+                    </a:p>
+                  </a:txBody>
+                  <a:tcPr anchor="ctr"/>
+                </a:tc>
+                <a:tc>
+                  <a:txBody>
+                    <a:bodyPr/>
+                    <a:lstStyle/>
+                    <a:p>
+                      <a:pPr algn="ctr"/>
+                      <a:r>
+                        <a:rPr sz="1200"/>
+                        <a:t>유의성</a:t>
+                      </a:r>
+                    </a:p>
+                  </a:txBody>
+                  <a:tcPr anchor="ctr"/>
+                </a:tc>
+                <a:tc>
+                  <a:txBody>
+                    <a:bodyPr/>
+                    <a:lstStyle/>
+                    <a:p>
+                      <a:pPr algn="ctr"/>
+                      <a:r>
+                        <a:rPr sz="1200"/>
+                        <a:t>peak slice / 방향</a:t>
+                      </a:r>
+                    </a:p>
+                  </a:txBody>
+                  <a:tcPr anchor="ctr"/>
+                </a:tc>
+                <a:extLst>
+                  <a:ext uri="{0D108BD9-81ED-4DB2-BD59-A6C34878D82A}">
+                    <a16:rowId xmlns:a16="http://schemas.microsoft.com/office/drawing/2014/main" val="10000"/>
+                  </a:ext>
+                </a:extLst>
+              </a:tr>
+              <a:tr h="333333">
+                <a:tc>
+                  <a:txBody>
+                    <a:bodyPr/>
+                    <a:lstStyle/>
+                    <a:p>
+                      <a:pPr algn="ctr"/>
+                      <a:r>
+                        <a:rPr sz="1200" dirty="0"/>
+                        <a:t>Gangnam</a:t>
+                      </a:r>
+                    </a:p>
+                  </a:txBody>
+                  <a:tcPr anchor="ctr"/>
+                </a:tc>
+                <a:tc>
+                  <a:txBody>
+                    <a:bodyPr/>
+                    <a:lstStyle/>
+                    <a:p>
+                      <a:pPr algn="ctr"/>
+                      <a:r>
+                        <a:rPr sz="1200"/>
+                        <a:t>0.0155</a:t>
+                      </a:r>
+                    </a:p>
+                  </a:txBody>
+                  <a:tcPr anchor="ctr"/>
+                </a:tc>
+                <a:tc>
+                  <a:txBody>
+                    <a:bodyPr/>
+                    <a:lstStyle/>
+                    <a:p>
+                      <a:pPr algn="ctr"/>
+                      <a:r>
+                        <a:rPr sz="1200"/>
+                        <a:t>0.227</a:t>
+                      </a:r>
+                    </a:p>
+                  </a:txBody>
+                  <a:tcPr anchor="ctr"/>
+                </a:tc>
+                <a:tc>
+                  <a:txBody>
+                    <a:bodyPr/>
+                    <a:lstStyle/>
+                    <a:p>
+                      <a:pPr algn="ctr"/>
+                      <a:r>
+                        <a:rPr sz="1200"/>
+                        <a:t>유의하지 않음</a:t>
+                      </a:r>
+                    </a:p>
+                  </a:txBody>
+                  <a:tcPr anchor="ctr"/>
+                </a:tc>
+                <a:tc>
+                  <a:txBody>
+                    <a:bodyPr/>
+                    <a:lstStyle/>
+                    <a:p>
+                      <a:pPr algn="ctr"/>
+                      <a:r>
+                        <a:rPr sz="1200"/>
+                        <a:t>slice 124</a:t>
+                      </a:r>
+                    </a:p>
+                  </a:txBody>
+                  <a:tcPr anchor="ctr"/>
+                </a:tc>
+                <a:extLst>
+                  <a:ext uri="{0D108BD9-81ED-4DB2-BD59-A6C34878D82A}">
+                    <a16:rowId xmlns:a16="http://schemas.microsoft.com/office/drawing/2014/main" val="10001"/>
+                  </a:ext>
+                </a:extLst>
+              </a:tr>
+              <a:tr h="333334">
+                <a:tc>
+                  <a:txBody>
+                    <a:bodyPr/>
+                    <a:lstStyle/>
+                    <a:p>
+                      <a:pPr algn="ctr"/>
+                      <a:r>
+                        <a:rPr sz="1200" dirty="0"/>
+                        <a:t>Sinchon</a:t>
+                      </a:r>
+                    </a:p>
+                  </a:txBody>
+                  <a:tcPr anchor="ctr"/>
+                </a:tc>
+                <a:tc>
+                  <a:txBody>
+                    <a:bodyPr/>
+                    <a:lstStyle/>
+                    <a:p>
+                      <a:pPr algn="ctr"/>
+                      <a:r>
+                        <a:rPr sz="1200"/>
+                        <a:t>0.0274</a:t>
+                      </a:r>
+                    </a:p>
+                  </a:txBody>
+                  <a:tcPr anchor="ctr"/>
+                </a:tc>
+                <a:tc>
+                  <a:txBody>
+                    <a:bodyPr/>
+                    <a:lstStyle/>
+                    <a:p>
+                      <a:pPr algn="ctr"/>
+                      <a:r>
+                        <a:rPr sz="1200" dirty="0"/>
+                        <a:t>0.0175</a:t>
+                      </a:r>
+                    </a:p>
+                  </a:txBody>
+                  <a:tcPr anchor="ctr"/>
+                </a:tc>
+                <a:tc>
+                  <a:txBody>
+                    <a:bodyPr/>
+                    <a:lstStyle/>
+                    <a:p>
+                      <a:pPr algn="ctr"/>
+                      <a:r>
+                        <a:rPr sz="1200" dirty="0" err="1"/>
+                        <a:t>유의함</a:t>
+                      </a:r>
+                      <a:endParaRPr sz="1200" dirty="0"/>
+                    </a:p>
+                  </a:txBody>
+                  <a:tcPr anchor="ctr"/>
+                </a:tc>
+                <a:tc>
+                  <a:txBody>
+                    <a:bodyPr/>
+                    <a:lstStyle/>
+                    <a:p>
+                      <a:pPr algn="ctr"/>
+                      <a:r>
+                        <a:rPr sz="1200" dirty="0"/>
+                        <a:t>slice 3</a:t>
+                      </a:r>
+                    </a:p>
+                  </a:txBody>
+                  <a:tcPr anchor="ctr"/>
+                </a:tc>
+                <a:extLst>
+                  <a:ext uri="{0D108BD9-81ED-4DB2-BD59-A6C34878D82A}">
+                    <a16:rowId xmlns:a16="http://schemas.microsoft.com/office/drawing/2014/main" val="10002"/>
+                  </a:ext>
+                </a:extLst>
+              </a:tr>
+            </a:tbl>
+          </a:graphicData>
+        </a:graphic>
+      </p:graphicFrame>
     </p:spTree>
     <p:extLst>
       <p:ext uri="{BB962C8B-B14F-4D97-AF65-F5344CB8AC3E}">

</xml_diff>